<commit_message>
Patellar strap cards: small study citations on cards 03-08
Co-Authored-By: Claude Opus 5.5 <noreply@anthropic.com>
Claude-Session: https://claude.ai/code/session_01GjYRY9i7LLGWcysU9DHVMw
</commit_message>
<xml_diff>
--- a/content/patellar-strap-runners/adobe-express/patellar-strap-runners-express.pptx
+++ b/content/patellar-strap-runners/adobe-express/patellar-strap-runners-express.pptx
@@ -1708,6 +1708,65 @@
           </a:p>
         </p:txBody>
       </p:sp>
+      <p:sp>
+        <p:nvSpPr>
+          <p:cNvPr id="13" name="텍스트: de Vries A et al. Scand "/>
+          <p:cNvSpPr txBox="1"/>
+          <p:nvPr/>
+        </p:nvSpPr>
+        <p:spPr>
+          <a:xfrm>
+            <a:off x="1334542" y="11651480"/>
+            <a:ext cx="7617916" cy="276225"/>
+          </a:xfrm>
+          <a:prstGeom prst="rect">
+            <a:avLst/>
+          </a:prstGeom>
+          <a:noFill/>
+          <a:ln>
+            <a:noFill/>
+          </a:ln>
+        </p:spPr>
+        <p:txBody>
+          <a:bodyPr vert="horz" wrap="none" lIns="0" tIns="0" rIns="0" bIns="0" rtlCol="0" anchor="ctr" anchorCtr="0">
+            <a:noAutofit/>
+          </a:bodyPr>
+          <a:lstStyle/>
+          <a:p>
+            <a:pPr algn="ctr">
+              <a:lnSpc>
+                <a:spcPct val="100000"/>
+              </a:lnSpc>
+              <a:spcBef>
+                <a:spcPts val="0"/>
+              </a:spcBef>
+              <a:spcAft>
+                <a:spcPts val="0"/>
+              </a:spcAft>
+              <a:buNone/>
+            </a:pPr>
+            <a:r>
+              <a:rPr lang="ko-KR" altLang="en-US" sz="1800" b="0" i="0" spc="-18" kern="0" dirty="0">
+                <a:solidFill>
+                  <a:srgbClr val="8A929C"/>
+                </a:solidFill>
+                <a:latin typeface="RCardnews W500" pitchFamily="34" charset="-127"/>
+                <a:ea typeface="RCardnews W500" pitchFamily="34" charset="-127"/>
+                <a:cs typeface="RCardnews W500" pitchFamily="34" charset="-127"/>
+              </a:rPr>
+              <a:t xml:space="preserve">de Vries A et al. Scand J Med Sci Sports 2016;26(10):1217–24</a:t>
+            </a:r>
+            <a:endParaRPr lang="ko-KR" altLang="en-US" sz="1800" b="0" i="0" spc="-18" kern="0" dirty="0">
+              <a:solidFill>
+                <a:srgbClr val="8A929C"/>
+              </a:solidFill>
+              <a:latin typeface="RCardnews W500" pitchFamily="34" charset="-127"/>
+              <a:ea typeface="RCardnews W500" pitchFamily="34" charset="-127"/>
+              <a:cs typeface="RCardnews W500" pitchFamily="34" charset="-127"/>
+            </a:endParaRPr>
+          </a:p>
+        </p:txBody>
+      </p:sp>
     </p:spTree>
   </p:cSld>
   <p:clrMapOvr>
@@ -1757,8 +1816,8 @@
         </p:blipFill>
         <p:spPr>
           <a:xfrm>
-            <a:off x="2952750" y="3215580"/>
-            <a:ext cx="4381500" cy="3810000"/>
+            <a:off x="3057525" y="3139380"/>
+            <a:ext cx="4171950" cy="3629025"/>
           </a:xfrm>
           <a:prstGeom prst="rect">
             <a:avLst/>
@@ -1922,7 +1981,7 @@
         </p:nvSpPr>
         <p:spPr>
           <a:xfrm>
-            <a:off x="3047702" y="7335333"/>
+            <a:off x="3047702" y="7078158"/>
             <a:ext cx="4191446" cy="476250"/>
           </a:xfrm>
           <a:prstGeom prst="rect">
@@ -1981,7 +2040,7 @@
         </p:nvSpPr>
         <p:spPr>
           <a:xfrm>
-            <a:off x="4409926" y="7803142"/>
+            <a:off x="4409926" y="7545967"/>
             <a:ext cx="1466850" cy="390525"/>
           </a:xfrm>
           <a:prstGeom prst="rect">
@@ -2040,7 +2099,7 @@
         </p:nvSpPr>
         <p:spPr>
           <a:xfrm>
-            <a:off x="3047702" y="8195262"/>
+            <a:off x="3047702" y="7938087"/>
             <a:ext cx="4191446" cy="476250"/>
           </a:xfrm>
           <a:prstGeom prst="rect">
@@ -2099,7 +2158,7 @@
         </p:nvSpPr>
         <p:spPr>
           <a:xfrm>
-            <a:off x="4409926" y="8663071"/>
+            <a:off x="4409926" y="8405896"/>
             <a:ext cx="1466850" cy="390525"/>
           </a:xfrm>
           <a:prstGeom prst="rect">
@@ -2158,7 +2217,7 @@
         </p:nvSpPr>
         <p:spPr>
           <a:xfrm>
-            <a:off x="1767334" y="9055191"/>
+            <a:off x="1767334" y="8798016"/>
             <a:ext cx="6752183" cy="476250"/>
           </a:xfrm>
           <a:prstGeom prst="rect">
@@ -2217,7 +2276,7 @@
         </p:nvSpPr>
         <p:spPr>
           <a:xfrm>
-            <a:off x="1565225" y="9559957"/>
+            <a:off x="1565225" y="9302782"/>
             <a:ext cx="7156400" cy="361950"/>
           </a:xfrm>
           <a:prstGeom prst="rect">
@@ -2276,7 +2335,7 @@
         </p:nvSpPr>
         <p:spPr>
           <a:xfrm>
-            <a:off x="4409926" y="9919180"/>
+            <a:off x="4409926" y="9662005"/>
             <a:ext cx="1466850" cy="390525"/>
           </a:xfrm>
           <a:prstGeom prst="rect">
@@ -2335,7 +2394,7 @@
         </p:nvSpPr>
         <p:spPr>
           <a:xfrm>
-            <a:off x="1787872" y="10311301"/>
+            <a:off x="1787872" y="10054126"/>
             <a:ext cx="6711107" cy="476250"/>
           </a:xfrm>
           <a:prstGeom prst="rect">
@@ -2394,7 +2453,7 @@
         </p:nvSpPr>
         <p:spPr>
           <a:xfrm>
-            <a:off x="659457" y="11078956"/>
+            <a:off x="659457" y="10745581"/>
             <a:ext cx="8968085" cy="476250"/>
           </a:xfrm>
           <a:prstGeom prst="rect">
@@ -2452,6 +2511,65 @@
               <a:latin typeface="RCardnews W750" pitchFamily="34" charset="-127"/>
               <a:ea typeface="RCardnews W750" pitchFamily="34" charset="-127"/>
               <a:cs typeface="RCardnews W750" pitchFamily="34" charset="-127"/>
+            </a:endParaRPr>
+          </a:p>
+        </p:txBody>
+      </p:sp>
+      <p:sp>
+        <p:nvSpPr>
+          <p:cNvPr id="15" name="텍스트: Lavagnino M et al. Sport"/>
+          <p:cNvSpPr txBox="1"/>
+          <p:nvPr/>
+        </p:nvSpPr>
+        <p:spPr>
+          <a:xfrm>
+            <a:off x="1820466" y="11651480"/>
+            <a:ext cx="6645920" cy="276225"/>
+          </a:xfrm>
+          <a:prstGeom prst="rect">
+            <a:avLst/>
+          </a:prstGeom>
+          <a:noFill/>
+          <a:ln>
+            <a:noFill/>
+          </a:ln>
+        </p:spPr>
+        <p:txBody>
+          <a:bodyPr vert="horz" wrap="none" lIns="0" tIns="0" rIns="0" bIns="0" rtlCol="0" anchor="ctr" anchorCtr="0">
+            <a:noAutofit/>
+          </a:bodyPr>
+          <a:lstStyle/>
+          <a:p>
+            <a:pPr algn="ctr">
+              <a:lnSpc>
+                <a:spcPct val="100000"/>
+              </a:lnSpc>
+              <a:spcBef>
+                <a:spcPts val="0"/>
+              </a:spcBef>
+              <a:spcAft>
+                <a:spcPts val="0"/>
+              </a:spcAft>
+              <a:buNone/>
+            </a:pPr>
+            <a:r>
+              <a:rPr lang="ko-KR" altLang="en-US" sz="1800" b="0" i="0" spc="-18" kern="0" dirty="0">
+                <a:solidFill>
+                  <a:srgbClr val="8A929C"/>
+                </a:solidFill>
+                <a:latin typeface="RCardnews W500" pitchFamily="34" charset="-127"/>
+                <a:ea typeface="RCardnews W500" pitchFamily="34" charset="-127"/>
+                <a:cs typeface="RCardnews W500" pitchFamily="34" charset="-127"/>
+              </a:rPr>
+              <a:t xml:space="preserve">Lavagnino M et al. Sports Health 2011;3(3):296–302</a:t>
+            </a:r>
+            <a:endParaRPr lang="ko-KR" altLang="en-US" sz="1800" b="0" i="0" spc="-18" kern="0" dirty="0">
+              <a:solidFill>
+                <a:srgbClr val="8A929C"/>
+              </a:solidFill>
+              <a:latin typeface="RCardnews W500" pitchFamily="34" charset="-127"/>
+              <a:ea typeface="RCardnews W500" pitchFamily="34" charset="-127"/>
+              <a:cs typeface="RCardnews W500" pitchFamily="34" charset="-127"/>
             </a:endParaRPr>
           </a:p>
         </p:txBody>
@@ -3107,6 +3225,65 @@
             <a:endParaRPr lang="ko-KR" altLang="en-US" sz="2850" b="0" i="0" spc="-57" kern="0" dirty="0">
               <a:solidFill>
                 <a:srgbClr val="121416"/>
+              </a:solidFill>
+              <a:latin typeface="RCardnews W500" pitchFamily="34" charset="-127"/>
+              <a:ea typeface="RCardnews W500" pitchFamily="34" charset="-127"/>
+              <a:cs typeface="RCardnews W500" pitchFamily="34" charset="-127"/>
+            </a:endParaRPr>
+          </a:p>
+        </p:txBody>
+      </p:sp>
+      <p:sp>
+        <p:nvSpPr>
+          <p:cNvPr id="13" name="텍스트: de Vries A et al. Scand "/>
+          <p:cNvSpPr txBox="1"/>
+          <p:nvPr/>
+        </p:nvSpPr>
+        <p:spPr>
+          <a:xfrm>
+            <a:off x="1334542" y="11651480"/>
+            <a:ext cx="7617916" cy="276225"/>
+          </a:xfrm>
+          <a:prstGeom prst="rect">
+            <a:avLst/>
+          </a:prstGeom>
+          <a:noFill/>
+          <a:ln>
+            <a:noFill/>
+          </a:ln>
+        </p:spPr>
+        <p:txBody>
+          <a:bodyPr vert="horz" wrap="none" lIns="0" tIns="0" rIns="0" bIns="0" rtlCol="0" anchor="ctr" anchorCtr="0">
+            <a:noAutofit/>
+          </a:bodyPr>
+          <a:lstStyle/>
+          <a:p>
+            <a:pPr algn="ctr">
+              <a:lnSpc>
+                <a:spcPct val="100000"/>
+              </a:lnSpc>
+              <a:spcBef>
+                <a:spcPts val="0"/>
+              </a:spcBef>
+              <a:spcAft>
+                <a:spcPts val="0"/>
+              </a:spcAft>
+              <a:buNone/>
+            </a:pPr>
+            <a:r>
+              <a:rPr lang="ko-KR" altLang="en-US" sz="1800" b="0" i="0" spc="-18" kern="0" dirty="0">
+                <a:solidFill>
+                  <a:srgbClr val="8A929C"/>
+                </a:solidFill>
+                <a:latin typeface="RCardnews W500" pitchFamily="34" charset="-127"/>
+                <a:ea typeface="RCardnews W500" pitchFamily="34" charset="-127"/>
+                <a:cs typeface="RCardnews W500" pitchFamily="34" charset="-127"/>
+              </a:rPr>
+              <a:t xml:space="preserve">de Vries A et al. Scand J Med Sci Sports 2016;26(10):1217–24</a:t>
+            </a:r>
+            <a:endParaRPr lang="ko-KR" altLang="en-US" sz="1800" b="0" i="0" spc="-18" kern="0" dirty="0">
+              <a:solidFill>
+                <a:srgbClr val="8A929C"/>
               </a:solidFill>
               <a:latin typeface="RCardnews W500" pitchFamily="34" charset="-127"/>
               <a:ea typeface="RCardnews W500" pitchFamily="34" charset="-127"/>
@@ -3164,8 +3341,8 @@
         </p:blipFill>
         <p:spPr>
           <a:xfrm>
-            <a:off x="914400" y="3291780"/>
-            <a:ext cx="8458200" cy="5334000"/>
+            <a:off x="914400" y="3177480"/>
+            <a:ext cx="8458200" cy="4667250"/>
           </a:xfrm>
           <a:prstGeom prst="rect">
             <a:avLst/>
@@ -3340,7 +3517,7 @@
         </p:nvSpPr>
         <p:spPr>
           <a:xfrm>
-            <a:off x="1835795" y="9070026"/>
+            <a:off x="1835795" y="8288976"/>
             <a:ext cx="6615261" cy="504825"/>
           </a:xfrm>
           <a:prstGeom prst="rect">
@@ -3399,7 +3576,7 @@
         </p:nvSpPr>
         <p:spPr>
           <a:xfrm>
-            <a:off x="657671" y="9665041"/>
+            <a:off x="657671" y="8883991"/>
             <a:ext cx="8971508" cy="504825"/>
           </a:xfrm>
           <a:prstGeom prst="rect">
@@ -3480,7 +3657,7 @@
         </p:nvSpPr>
         <p:spPr>
           <a:xfrm>
-            <a:off x="1767185" y="10436459"/>
+            <a:off x="1767185" y="9579209"/>
             <a:ext cx="6752630" cy="409575"/>
           </a:xfrm>
           <a:prstGeom prst="rect">
@@ -3539,7 +3716,7 @@
         </p:nvSpPr>
         <p:spPr>
           <a:xfrm>
-            <a:off x="1814959" y="10916430"/>
+            <a:off x="1814959" y="10059180"/>
             <a:ext cx="6656933" cy="409575"/>
           </a:xfrm>
           <a:prstGeom prst="rect">
@@ -3582,6 +3759,183 @@
             <a:endParaRPr lang="ko-KR" altLang="en-US" sz="2700" b="0" i="0" spc="-54" kern="0" dirty="0">
               <a:solidFill>
                 <a:srgbClr val="5E6570"/>
+              </a:solidFill>
+              <a:latin typeface="RCardnews W500" pitchFamily="34" charset="-127"/>
+              <a:ea typeface="RCardnews W500" pitchFamily="34" charset="-127"/>
+              <a:cs typeface="RCardnews W500" pitchFamily="34" charset="-127"/>
+            </a:endParaRPr>
+          </a:p>
+        </p:txBody>
+      </p:sp>
+      <p:sp>
+        <p:nvSpPr>
+          <p:cNvPr id="10" name="텍스트: de Vries A et al. Scand "/>
+          <p:cNvSpPr txBox="1"/>
+          <p:nvPr/>
+        </p:nvSpPr>
+        <p:spPr>
+          <a:xfrm>
+            <a:off x="1334542" y="11057358"/>
+            <a:ext cx="7617916" cy="276225"/>
+          </a:xfrm>
+          <a:prstGeom prst="rect">
+            <a:avLst/>
+          </a:prstGeom>
+          <a:noFill/>
+          <a:ln>
+            <a:noFill/>
+          </a:ln>
+        </p:spPr>
+        <p:txBody>
+          <a:bodyPr vert="horz" wrap="none" lIns="0" tIns="0" rIns="0" bIns="0" rtlCol="0" anchor="ctr" anchorCtr="0">
+            <a:noAutofit/>
+          </a:bodyPr>
+          <a:lstStyle/>
+          <a:p>
+            <a:pPr algn="ctr">
+              <a:lnSpc>
+                <a:spcPct val="100000"/>
+              </a:lnSpc>
+              <a:spcBef>
+                <a:spcPts val="0"/>
+              </a:spcBef>
+              <a:spcAft>
+                <a:spcPts val="0"/>
+              </a:spcAft>
+              <a:buNone/>
+            </a:pPr>
+            <a:r>
+              <a:rPr lang="ko-KR" altLang="en-US" sz="1800" b="0" i="0" spc="-18" kern="0" dirty="0">
+                <a:solidFill>
+                  <a:srgbClr val="8A929C"/>
+                </a:solidFill>
+                <a:latin typeface="RCardnews W500" pitchFamily="34" charset="-127"/>
+                <a:ea typeface="RCardnews W500" pitchFamily="34" charset="-127"/>
+                <a:cs typeface="RCardnews W500" pitchFamily="34" charset="-127"/>
+              </a:rPr>
+              <a:t xml:space="preserve">de Vries A et al. Scand J Med Sci Sports 2016;26(10):1217–24</a:t>
+            </a:r>
+            <a:endParaRPr lang="ko-KR" altLang="en-US" sz="1800" b="0" i="0" spc="-18" kern="0" dirty="0">
+              <a:solidFill>
+                <a:srgbClr val="8A929C"/>
+              </a:solidFill>
+              <a:latin typeface="RCardnews W500" pitchFamily="34" charset="-127"/>
+              <a:ea typeface="RCardnews W500" pitchFamily="34" charset="-127"/>
+              <a:cs typeface="RCardnews W500" pitchFamily="34" charset="-127"/>
+            </a:endParaRPr>
+          </a:p>
+        </p:txBody>
+      </p:sp>
+      <p:sp>
+        <p:nvSpPr>
+          <p:cNvPr id="11" name="텍스트: Dar G, Mei-Dan E. Prosth"/>
+          <p:cNvSpPr txBox="1"/>
+          <p:nvPr/>
+        </p:nvSpPr>
+        <p:spPr>
+          <a:xfrm>
+            <a:off x="1707654" y="11354419"/>
+            <a:ext cx="6871692" cy="276225"/>
+          </a:xfrm>
+          <a:prstGeom prst="rect">
+            <a:avLst/>
+          </a:prstGeom>
+          <a:noFill/>
+          <a:ln>
+            <a:noFill/>
+          </a:ln>
+        </p:spPr>
+        <p:txBody>
+          <a:bodyPr vert="horz" wrap="none" lIns="0" tIns="0" rIns="0" bIns="0" rtlCol="0" anchor="ctr" anchorCtr="0">
+            <a:noAutofit/>
+          </a:bodyPr>
+          <a:lstStyle/>
+          <a:p>
+            <a:pPr algn="ctr">
+              <a:lnSpc>
+                <a:spcPct val="100000"/>
+              </a:lnSpc>
+              <a:spcBef>
+                <a:spcPts val="0"/>
+              </a:spcBef>
+              <a:spcAft>
+                <a:spcPts val="0"/>
+              </a:spcAft>
+              <a:buNone/>
+            </a:pPr>
+            <a:r>
+              <a:rPr lang="ko-KR" altLang="en-US" sz="1800" b="0" i="0" spc="-18" kern="0" dirty="0">
+                <a:solidFill>
+                  <a:srgbClr val="8A929C"/>
+                </a:solidFill>
+                <a:latin typeface="RCardnews W500" pitchFamily="34" charset="-127"/>
+                <a:ea typeface="RCardnews W500" pitchFamily="34" charset="-127"/>
+                <a:cs typeface="RCardnews W500" pitchFamily="34" charset="-127"/>
+              </a:rPr>
+              <a:t xml:space="preserve">Dar G, Mei-Dan E. Prosthet Orthot Int 2019;43(1):21–7</a:t>
+            </a:r>
+            <a:endParaRPr lang="ko-KR" altLang="en-US" sz="1800" b="0" i="0" spc="-18" kern="0" dirty="0">
+              <a:solidFill>
+                <a:srgbClr val="8A929C"/>
+              </a:solidFill>
+              <a:latin typeface="RCardnews W500" pitchFamily="34" charset="-127"/>
+              <a:ea typeface="RCardnews W500" pitchFamily="34" charset="-127"/>
+              <a:cs typeface="RCardnews W500" pitchFamily="34" charset="-127"/>
+            </a:endParaRPr>
+          </a:p>
+        </p:txBody>
+      </p:sp>
+      <p:sp>
+        <p:nvSpPr>
+          <p:cNvPr id="12" name="텍스트: Willy RW et al. J Orthop"/>
+          <p:cNvSpPr txBox="1"/>
+          <p:nvPr/>
+        </p:nvSpPr>
+        <p:spPr>
+          <a:xfrm>
+            <a:off x="1251347" y="11651480"/>
+            <a:ext cx="7784157" cy="276225"/>
+          </a:xfrm>
+          <a:prstGeom prst="rect">
+            <a:avLst/>
+          </a:prstGeom>
+          <a:noFill/>
+          <a:ln>
+            <a:noFill/>
+          </a:ln>
+        </p:spPr>
+        <p:txBody>
+          <a:bodyPr vert="horz" wrap="none" lIns="0" tIns="0" rIns="0" bIns="0" rtlCol="0" anchor="ctr" anchorCtr="0">
+            <a:noAutofit/>
+          </a:bodyPr>
+          <a:lstStyle/>
+          <a:p>
+            <a:pPr algn="ctr">
+              <a:lnSpc>
+                <a:spcPct val="100000"/>
+              </a:lnSpc>
+              <a:spcBef>
+                <a:spcPts val="0"/>
+              </a:spcBef>
+              <a:spcAft>
+                <a:spcPts val="0"/>
+              </a:spcAft>
+              <a:buNone/>
+            </a:pPr>
+            <a:r>
+              <a:rPr lang="ko-KR" altLang="en-US" sz="1800" b="0" i="0" spc="-18" kern="0" dirty="0">
+                <a:solidFill>
+                  <a:srgbClr val="8A929C"/>
+                </a:solidFill>
+                <a:latin typeface="RCardnews W500" pitchFamily="34" charset="-127"/>
+                <a:ea typeface="RCardnews W500" pitchFamily="34" charset="-127"/>
+                <a:cs typeface="RCardnews W500" pitchFamily="34" charset="-127"/>
+              </a:rPr>
+              <a:t xml:space="preserve">Willy RW et al. J Orthop Sports Phys Ther 2019;49(9):CPG1–95</a:t>
+            </a:r>
+            <a:endParaRPr lang="ko-KR" altLang="en-US" sz="1800" b="0" i="0" spc="-18" kern="0" dirty="0">
+              <a:solidFill>
+                <a:srgbClr val="8A929C"/>
               </a:solidFill>
               <a:latin typeface="RCardnews W500" pitchFamily="34" charset="-127"/>
               <a:ea typeface="RCardnews W500" pitchFamily="34" charset="-127"/>
@@ -3639,8 +3993,8 @@
         </p:blipFill>
         <p:spPr>
           <a:xfrm>
-            <a:off x="914400" y="3367980"/>
-            <a:ext cx="8458200" cy="5715000"/>
+            <a:off x="914400" y="3215580"/>
+            <a:ext cx="8458200" cy="5429250"/>
           </a:xfrm>
           <a:prstGeom prst="rect">
             <a:avLst/>
@@ -3815,7 +4169,7 @@
         </p:nvSpPr>
         <p:spPr>
           <a:xfrm>
-            <a:off x="1558826" y="9603426"/>
+            <a:off x="1558826" y="9165276"/>
             <a:ext cx="7169348" cy="504825"/>
           </a:xfrm>
           <a:prstGeom prst="rect">
@@ -3874,7 +4228,7 @@
         </p:nvSpPr>
         <p:spPr>
           <a:xfrm>
-            <a:off x="1566118" y="10198441"/>
+            <a:off x="1566118" y="9760291"/>
             <a:ext cx="7154763" cy="504825"/>
           </a:xfrm>
           <a:prstGeom prst="rect">
@@ -3955,7 +4309,7 @@
         </p:nvSpPr>
         <p:spPr>
           <a:xfrm>
-            <a:off x="822275" y="10969859"/>
+            <a:off x="822275" y="10531709"/>
             <a:ext cx="8642300" cy="409575"/>
           </a:xfrm>
           <a:prstGeom prst="rect">
@@ -3998,6 +4352,124 @@
             <a:endParaRPr lang="ko-KR" altLang="en-US" sz="2700" b="0" i="0" spc="-54" kern="0" dirty="0">
               <a:solidFill>
                 <a:srgbClr val="5E6570"/>
+              </a:solidFill>
+              <a:latin typeface="RCardnews W500" pitchFamily="34" charset="-127"/>
+              <a:ea typeface="RCardnews W500" pitchFamily="34" charset="-127"/>
+              <a:cs typeface="RCardnews W500" pitchFamily="34" charset="-127"/>
+            </a:endParaRPr>
+          </a:p>
+        </p:txBody>
+      </p:sp>
+      <p:sp>
+        <p:nvSpPr>
+          <p:cNvPr id="9" name="텍스트: Breda SJ et al. Br J Spo"/>
+          <p:cNvSpPr txBox="1"/>
+          <p:nvPr/>
+        </p:nvSpPr>
+        <p:spPr>
+          <a:xfrm>
+            <a:off x="2116187" y="11354419"/>
+            <a:ext cx="6054626" cy="276225"/>
+          </a:xfrm>
+          <a:prstGeom prst="rect">
+            <a:avLst/>
+          </a:prstGeom>
+          <a:noFill/>
+          <a:ln>
+            <a:noFill/>
+          </a:ln>
+        </p:spPr>
+        <p:txBody>
+          <a:bodyPr vert="horz" wrap="none" lIns="0" tIns="0" rIns="0" bIns="0" rtlCol="0" anchor="ctr" anchorCtr="0">
+            <a:noAutofit/>
+          </a:bodyPr>
+          <a:lstStyle/>
+          <a:p>
+            <a:pPr algn="ctr">
+              <a:lnSpc>
+                <a:spcPct val="100000"/>
+              </a:lnSpc>
+              <a:spcBef>
+                <a:spcPts val="0"/>
+              </a:spcBef>
+              <a:spcAft>
+                <a:spcPts val="0"/>
+              </a:spcAft>
+              <a:buNone/>
+            </a:pPr>
+            <a:r>
+              <a:rPr lang="ko-KR" altLang="en-US" sz="1800" b="0" i="0" spc="-18" kern="0" dirty="0">
+                <a:solidFill>
+                  <a:srgbClr val="8A929C"/>
+                </a:solidFill>
+                <a:latin typeface="RCardnews W500" pitchFamily="34" charset="-127"/>
+                <a:ea typeface="RCardnews W500" pitchFamily="34" charset="-127"/>
+                <a:cs typeface="RCardnews W500" pitchFamily="34" charset="-127"/>
+              </a:rPr>
+              <a:t xml:space="preserve">Breda SJ et al. Br J Sports Med 2021;55:501–9</a:t>
+            </a:r>
+            <a:endParaRPr lang="ko-KR" altLang="en-US" sz="1800" b="0" i="0" spc="-18" kern="0" dirty="0">
+              <a:solidFill>
+                <a:srgbClr val="8A929C"/>
+              </a:solidFill>
+              <a:latin typeface="RCardnews W500" pitchFamily="34" charset="-127"/>
+              <a:ea typeface="RCardnews W500" pitchFamily="34" charset="-127"/>
+              <a:cs typeface="RCardnews W500" pitchFamily="34" charset="-127"/>
+            </a:endParaRPr>
+          </a:p>
+        </p:txBody>
+      </p:sp>
+      <p:sp>
+        <p:nvSpPr>
+          <p:cNvPr id="10" name="텍스트: Collins NJ et al. Br J S"/>
+          <p:cNvSpPr txBox="1"/>
+          <p:nvPr/>
+        </p:nvSpPr>
+        <p:spPr>
+          <a:xfrm>
+            <a:off x="1989832" y="11651480"/>
+            <a:ext cx="6307187" cy="276225"/>
+          </a:xfrm>
+          <a:prstGeom prst="rect">
+            <a:avLst/>
+          </a:prstGeom>
+          <a:noFill/>
+          <a:ln>
+            <a:noFill/>
+          </a:ln>
+        </p:spPr>
+        <p:txBody>
+          <a:bodyPr vert="horz" wrap="none" lIns="0" tIns="0" rIns="0" bIns="0" rtlCol="0" anchor="ctr" anchorCtr="0">
+            <a:noAutofit/>
+          </a:bodyPr>
+          <a:lstStyle/>
+          <a:p>
+            <a:pPr algn="ctr">
+              <a:lnSpc>
+                <a:spcPct val="100000"/>
+              </a:lnSpc>
+              <a:spcBef>
+                <a:spcPts val="0"/>
+              </a:spcBef>
+              <a:spcAft>
+                <a:spcPts val="0"/>
+              </a:spcAft>
+              <a:buNone/>
+            </a:pPr>
+            <a:r>
+              <a:rPr lang="ko-KR" altLang="en-US" sz="1800" b="0" i="0" spc="-18" kern="0" dirty="0">
+                <a:solidFill>
+                  <a:srgbClr val="8A929C"/>
+                </a:solidFill>
+                <a:latin typeface="RCardnews W500" pitchFamily="34" charset="-127"/>
+                <a:ea typeface="RCardnews W500" pitchFamily="34" charset="-127"/>
+                <a:cs typeface="RCardnews W500" pitchFamily="34" charset="-127"/>
+              </a:rPr>
+              <a:t xml:space="preserve">Collins NJ et al. Br J Sports Med 2018;52:1170–8</a:t>
+            </a:r>
+            <a:endParaRPr lang="ko-KR" altLang="en-US" sz="1800" b="0" i="0" spc="-18" kern="0" dirty="0">
+              <a:solidFill>
+                <a:srgbClr val="8A929C"/>
               </a:solidFill>
               <a:latin typeface="RCardnews W500" pitchFamily="34" charset="-127"/>
               <a:ea typeface="RCardnews W500" pitchFamily="34" charset="-127"/>
@@ -4709,6 +5181,65 @@
               <a:latin typeface="RCardnews W700" pitchFamily="34" charset="-127"/>
               <a:ea typeface="RCardnews W700" pitchFamily="34" charset="-127"/>
               <a:cs typeface="RCardnews W700" pitchFamily="34" charset="-127"/>
+            </a:endParaRPr>
+          </a:p>
+        </p:txBody>
+      </p:sp>
+      <p:sp>
+        <p:nvSpPr>
+          <p:cNvPr id="14" name="텍스트: de Vries A et al. Scand "/>
+          <p:cNvSpPr txBox="1"/>
+          <p:nvPr/>
+        </p:nvSpPr>
+        <p:spPr>
+          <a:xfrm>
+            <a:off x="1334542" y="11651480"/>
+            <a:ext cx="7617916" cy="276225"/>
+          </a:xfrm>
+          <a:prstGeom prst="rect">
+            <a:avLst/>
+          </a:prstGeom>
+          <a:noFill/>
+          <a:ln>
+            <a:noFill/>
+          </a:ln>
+        </p:spPr>
+        <p:txBody>
+          <a:bodyPr vert="horz" wrap="none" lIns="0" tIns="0" rIns="0" bIns="0" rtlCol="0" anchor="ctr" anchorCtr="0">
+            <a:noAutofit/>
+          </a:bodyPr>
+          <a:lstStyle/>
+          <a:p>
+            <a:pPr algn="ctr">
+              <a:lnSpc>
+                <a:spcPct val="100000"/>
+              </a:lnSpc>
+              <a:spcBef>
+                <a:spcPts val="0"/>
+              </a:spcBef>
+              <a:spcAft>
+                <a:spcPts val="0"/>
+              </a:spcAft>
+              <a:buNone/>
+            </a:pPr>
+            <a:r>
+              <a:rPr lang="ko-KR" altLang="en-US" sz="1800" b="0" i="0" spc="-18" kern="0" dirty="0">
+                <a:solidFill>
+                  <a:srgbClr val="8A929C"/>
+                </a:solidFill>
+                <a:latin typeface="RCardnews W500" pitchFamily="34" charset="-127"/>
+                <a:ea typeface="RCardnews W500" pitchFamily="34" charset="-127"/>
+                <a:cs typeface="RCardnews W500" pitchFamily="34" charset="-127"/>
+              </a:rPr>
+              <a:t xml:space="preserve">de Vries A et al. Scand J Med Sci Sports 2016;26(10):1217–24</a:t>
+            </a:r>
+            <a:endParaRPr lang="ko-KR" altLang="en-US" sz="1800" b="0" i="0" spc="-18" kern="0" dirty="0">
+              <a:solidFill>
+                <a:srgbClr val="8A929C"/>
+              </a:solidFill>
+              <a:latin typeface="RCardnews W500" pitchFamily="34" charset="-127"/>
+              <a:ea typeface="RCardnews W500" pitchFamily="34" charset="-127"/>
+              <a:cs typeface="RCardnews W500" pitchFamily="34" charset="-127"/>
             </a:endParaRPr>
           </a:p>
         </p:txBody>

</xml_diff>

<commit_message>
Patellar strap card 07: progressive tendon loading message, no scores
Co-Authored-By: Claude Opus 5.5 <noreply@anthropic.com>
Claude-Session: https://claude.ai/code/session_01GjYRY9i7LLGWcysU9DHVMw
</commit_message>
<xml_diff>
--- a/content/patellar-strap-runners/adobe-express/patellar-strap-runners-express.pptx
+++ b/content/patellar-strap-runners/adobe-express/patellar-strap-runners-express.pptx
@@ -3994,7 +3994,7 @@
         <p:spPr>
           <a:xfrm>
             <a:off x="914400" y="3215580"/>
-            <a:ext cx="8458200" cy="5429250"/>
+            <a:ext cx="8458200" cy="4762500"/>
           </a:xfrm>
           <a:prstGeom prst="rect">
             <a:avLst/>
@@ -4034,14 +4034,14 @@
       </p:sp>
       <p:sp>
         <p:nvSpPr>
-          <p:cNvPr id="4" name="텍스트: 힘줄은"/>
-          <p:cNvSpPr txBox="1"/>
-          <p:nvPr/>
-        </p:nvSpPr>
-        <p:spPr>
-          <a:xfrm>
-            <a:off x="3509814" y="1029081"/>
-            <a:ext cx="3267373" cy="962025"/>
+          <p:cNvPr id="4" name="텍스트: 힘줄은 점진적인 부하로"/>
+          <p:cNvSpPr txBox="1"/>
+          <p:nvPr/>
+        </p:nvSpPr>
+        <p:spPr>
+          <a:xfrm>
+            <a:off x="835372" y="1029081"/>
+            <a:ext cx="8616107" cy="962025"/>
           </a:xfrm>
           <a:prstGeom prst="rect">
             <a:avLst/>
@@ -4078,7 +4078,29 @@
                 <a:ea typeface="RCardnews W850" pitchFamily="34" charset="-127"/>
                 <a:cs typeface="RCardnews W850" pitchFamily="34" charset="-127"/>
               </a:rPr>
-              <a:t xml:space="preserve">힘줄은</a:t>
+              <a:t xml:space="preserve">힘줄은 </a:t>
+            </a:r>
+            <a:r>
+              <a:rPr lang="ko-KR" altLang="en-US" sz="6300" b="0" i="0" spc="-220" kern="0" dirty="0">
+                <a:solidFill>
+                  <a:srgbClr val="0879D8"/>
+                </a:solidFill>
+                <a:latin typeface="RCardnews W850" pitchFamily="34" charset="-127"/>
+                <a:ea typeface="RCardnews W850" pitchFamily="34" charset="-127"/>
+                <a:cs typeface="RCardnews W850" pitchFamily="34" charset="-127"/>
+              </a:rPr>
+              <a:t xml:space="preserve">점진적인 부하</a:t>
+            </a:r>
+            <a:r>
+              <a:rPr lang="ko-KR" altLang="en-US" sz="6300" b="0" i="0" spc="-220" kern="0" dirty="0">
+                <a:solidFill>
+                  <a:srgbClr val="121416"/>
+                </a:solidFill>
+                <a:latin typeface="RCardnews W850" pitchFamily="34" charset="-127"/>
+                <a:ea typeface="RCardnews W850" pitchFamily="34" charset="-127"/>
+                <a:cs typeface="RCardnews W850" pitchFamily="34" charset="-127"/>
+              </a:rPr>
+              <a:t xml:space="preserve">로</a:t>
             </a:r>
             <a:endParaRPr lang="ko-KR" altLang="en-US" sz="6300" b="0" i="0" spc="-220" kern="0" dirty="0">
               <a:solidFill>
@@ -4093,14 +4115,14 @@
       </p:sp>
       <p:sp>
         <p:nvSpPr>
-          <p:cNvPr id="5" name="텍스트: 쓰면서 튼튼해집니다"/>
-          <p:cNvSpPr txBox="1"/>
-          <p:nvPr/>
-        </p:nvSpPr>
-        <p:spPr>
-          <a:xfrm>
-            <a:off x="1287512" y="1989171"/>
-            <a:ext cx="7711976" cy="962025"/>
+          <p:cNvPr id="5" name="텍스트: 좋아집니다"/>
+          <p:cNvSpPr txBox="1"/>
+          <p:nvPr/>
+        </p:nvSpPr>
+        <p:spPr>
+          <a:xfrm>
+            <a:off x="2801689" y="1989171"/>
+            <a:ext cx="4683472" cy="962025"/>
           </a:xfrm>
           <a:prstGeom prst="rect">
             <a:avLst/>
@@ -4131,24 +4153,13 @@
             <a:r>
               <a:rPr lang="ko-KR" altLang="en-US" sz="6300" b="0" i="0" spc="-220" kern="0" dirty="0">
                 <a:solidFill>
-                  <a:srgbClr val="0879D8"/>
+                  <a:srgbClr val="121416"/>
                 </a:solidFill>
                 <a:latin typeface="RCardnews W850" pitchFamily="34" charset="-127"/>
                 <a:ea typeface="RCardnews W850" pitchFamily="34" charset="-127"/>
                 <a:cs typeface="RCardnews W850" pitchFamily="34" charset="-127"/>
               </a:rPr>
-              <a:t xml:space="preserve">쓰면서</a:t>
-            </a:r>
-            <a:r>
-              <a:rPr lang="ko-KR" altLang="en-US" sz="6300" b="0" i="0" spc="-220" kern="0" dirty="0">
-                <a:solidFill>
-                  <a:srgbClr val="121416"/>
-                </a:solidFill>
-                <a:latin typeface="RCardnews W850" pitchFamily="34" charset="-127"/>
-                <a:ea typeface="RCardnews W850" pitchFamily="34" charset="-127"/>
-                <a:cs typeface="RCardnews W850" pitchFamily="34" charset="-127"/>
-              </a:rPr>
-              <a:t xml:space="preserve"> 튼튼해집니다</a:t>
+              <a:t xml:space="preserve">좋아집니다</a:t>
             </a:r>
             <a:endParaRPr lang="ko-KR" altLang="en-US" sz="6300" b="0" i="0" spc="-220" kern="0" dirty="0">
               <a:solidFill>
@@ -4163,14 +4174,14 @@
       </p:sp>
       <p:sp>
         <p:nvSpPr>
-          <p:cNvPr id="6" name="텍스트: 무게를 조금씩 올린 힘줄 운동 24주,"/>
-          <p:cNvSpPr txBox="1"/>
-          <p:nvPr/>
-        </p:nvSpPr>
-        <p:spPr>
-          <a:xfrm>
-            <a:off x="1558826" y="9165276"/>
-            <a:ext cx="7169348" cy="504825"/>
+          <p:cNvPr id="6" name="텍스트: 통증이 버틸 만한 범위에서 무게와 강도를"/>
+          <p:cNvSpPr txBox="1"/>
+          <p:nvPr/>
+        </p:nvSpPr>
+        <p:spPr>
+          <a:xfrm>
+            <a:off x="1093440" y="8498526"/>
+            <a:ext cx="8100120" cy="504825"/>
           </a:xfrm>
           <a:prstGeom prst="rect">
             <a:avLst/>
@@ -4207,7 +4218,7 @@
                 <a:ea typeface="RCardnews W500" pitchFamily="34" charset="-127"/>
                 <a:cs typeface="RCardnews W500" pitchFamily="34" charset="-127"/>
               </a:rPr>
-              <a:t xml:space="preserve">무게를 조금씩 올린 힘줄 운동 24주,</a:t>
+              <a:t xml:space="preserve">통증이 버틸 만한 범위에서 무게와 강도를</a:t>
             </a:r>
             <a:endParaRPr lang="ko-KR" altLang="en-US" sz="3300" b="0" i="0" spc="-66" kern="0" dirty="0">
               <a:solidFill>
@@ -4222,41 +4233,52 @@
       </p:sp>
       <p:sp>
         <p:nvSpPr>
-          <p:cNvPr id="7" name="텍스트: 기능 점수 +28점 (기존 운동 +18점)"/>
-          <p:cNvSpPr txBox="1"/>
-          <p:nvPr/>
-        </p:nvSpPr>
-        <p:spPr>
-          <a:xfrm>
-            <a:off x="1566118" y="9760291"/>
-            <a:ext cx="7154763" cy="504825"/>
-          </a:xfrm>
-          <a:prstGeom prst="rect">
-            <a:avLst/>
-          </a:prstGeom>
-          <a:noFill/>
-          <a:ln>
-            <a:noFill/>
-          </a:ln>
-        </p:spPr>
-        <p:txBody>
-          <a:bodyPr vert="horz" wrap="none" lIns="0" tIns="0" rIns="0" bIns="0" rtlCol="0" anchor="ctr" anchorCtr="0">
-            <a:noAutofit/>
-          </a:bodyPr>
-          <a:lstStyle/>
-          <a:p>
-            <a:pPr algn="ctr">
-              <a:lnSpc>
-                <a:spcPct val="100000"/>
-              </a:lnSpc>
-              <a:spcBef>
-                <a:spcPts val="0"/>
-              </a:spcBef>
-              <a:spcAft>
-                <a:spcPts val="0"/>
-              </a:spcAft>
-              <a:buNone/>
-            </a:pPr>
+          <p:cNvPr id="7" name="텍스트: 조금씩 늘려 힘줄에 부하를 주는 운동,"/>
+          <p:cNvSpPr txBox="1"/>
+          <p:nvPr/>
+        </p:nvSpPr>
+        <p:spPr>
+          <a:xfrm>
+            <a:off x="1412081" y="9093541"/>
+            <a:ext cx="7462689" cy="504825"/>
+          </a:xfrm>
+          <a:prstGeom prst="rect">
+            <a:avLst/>
+          </a:prstGeom>
+          <a:noFill/>
+          <a:ln>
+            <a:noFill/>
+          </a:ln>
+        </p:spPr>
+        <p:txBody>
+          <a:bodyPr vert="horz" wrap="none" lIns="0" tIns="0" rIns="0" bIns="0" rtlCol="0" anchor="ctr" anchorCtr="0">
+            <a:noAutofit/>
+          </a:bodyPr>
+          <a:lstStyle/>
+          <a:p>
+            <a:pPr algn="ctr">
+              <a:lnSpc>
+                <a:spcPct val="100000"/>
+              </a:lnSpc>
+              <a:spcBef>
+                <a:spcPts val="0"/>
+              </a:spcBef>
+              <a:spcAft>
+                <a:spcPts val="0"/>
+              </a:spcAft>
+              <a:buNone/>
+            </a:pPr>
+            <a:r>
+              <a:rPr lang="ko-KR" altLang="en-US" sz="3300" b="0" i="0" spc="-66" kern="0" dirty="0">
+                <a:solidFill>
+                  <a:srgbClr val="121416"/>
+                </a:solidFill>
+                <a:latin typeface="RCardnews W750" pitchFamily="34" charset="-127"/>
+                <a:ea typeface="RCardnews W750" pitchFamily="34" charset="-127"/>
+                <a:cs typeface="RCardnews W750" pitchFamily="34" charset="-127"/>
+              </a:rPr>
+              <a:t xml:space="preserve">조금씩 늘려 힘줄에 부하를 주는 운동</a:t>
+            </a:r>
             <a:r>
               <a:rPr lang="ko-KR" altLang="en-US" sz="3300" b="0" i="0" spc="-66" kern="0" dirty="0">
                 <a:solidFill>
@@ -4266,19 +4288,56 @@
                 <a:ea typeface="RCardnews W500" pitchFamily="34" charset="-127"/>
                 <a:cs typeface="RCardnews W500" pitchFamily="34" charset="-127"/>
               </a:rPr>
-              <a:t xml:space="preserve">기능 점수 </a:t>
-            </a:r>
-            <a:r>
-              <a:rPr lang="ko-KR" altLang="en-US" sz="3300" b="0" i="0" spc="-66" kern="0" dirty="0">
-                <a:solidFill>
-                  <a:srgbClr val="0879D8"/>
-                </a:solidFill>
-                <a:latin typeface="RCardnews W750" pitchFamily="34" charset="-127"/>
-                <a:ea typeface="RCardnews W750" pitchFamily="34" charset="-127"/>
-                <a:cs typeface="RCardnews W750" pitchFamily="34" charset="-127"/>
-              </a:rPr>
-              <a:t xml:space="preserve">+28점</a:t>
-            </a:r>
+              <a:t xml:space="preserve">,</a:t>
+            </a:r>
+            <a:endParaRPr lang="ko-KR" altLang="en-US" sz="3300" b="0" i="0" spc="-66" kern="0" dirty="0">
+              <a:solidFill>
+                <a:srgbClr val="121416"/>
+              </a:solidFill>
+              <a:latin typeface="RCardnews W500" pitchFamily="34" charset="-127"/>
+              <a:ea typeface="RCardnews W500" pitchFamily="34" charset="-127"/>
+              <a:cs typeface="RCardnews W500" pitchFamily="34" charset="-127"/>
+            </a:endParaRPr>
+          </a:p>
+        </p:txBody>
+      </p:sp>
+      <p:sp>
+        <p:nvSpPr>
+          <p:cNvPr id="8" name="텍스트: 이게 회복의 핵심입니다."/>
+          <p:cNvSpPr txBox="1"/>
+          <p:nvPr/>
+        </p:nvSpPr>
+        <p:spPr>
+          <a:xfrm>
+            <a:off x="2518618" y="9688556"/>
+            <a:ext cx="5249763" cy="504825"/>
+          </a:xfrm>
+          <a:prstGeom prst="rect">
+            <a:avLst/>
+          </a:prstGeom>
+          <a:noFill/>
+          <a:ln>
+            <a:noFill/>
+          </a:ln>
+        </p:spPr>
+        <p:txBody>
+          <a:bodyPr vert="horz" wrap="none" lIns="0" tIns="0" rIns="0" bIns="0" rtlCol="0" anchor="ctr" anchorCtr="0">
+            <a:noAutofit/>
+          </a:bodyPr>
+          <a:lstStyle/>
+          <a:p>
+            <a:pPr algn="ctr">
+              <a:lnSpc>
+                <a:spcPct val="100000"/>
+              </a:lnSpc>
+              <a:spcBef>
+                <a:spcPts val="0"/>
+              </a:spcBef>
+              <a:spcAft>
+                <a:spcPts val="0"/>
+              </a:spcAft>
+              <a:buNone/>
+            </a:pPr>
             <a:r>
               <a:rPr lang="ko-KR" altLang="en-US" sz="3300" b="0" i="0" spc="-66" kern="0" dirty="0">
                 <a:solidFill>
@@ -4288,7 +4347,7 @@
                 <a:ea typeface="RCardnews W500" pitchFamily="34" charset="-127"/>
                 <a:cs typeface="RCardnews W500" pitchFamily="34" charset="-127"/>
               </a:rPr>
-              <a:t xml:space="preserve"> (기존 운동 +18점)</a:t>
+              <a:t xml:space="preserve">이게 회복의 핵심입니다.</a:t>
             </a:r>
             <a:endParaRPr lang="ko-KR" altLang="en-US" sz="3300" b="0" i="0" spc="-66" kern="0" dirty="0">
               <a:solidFill>
@@ -4303,13 +4362,13 @@
       </p:sp>
       <p:sp>
         <p:nvSpPr>
-          <p:cNvPr id="8" name="텍스트: 무릎뼈 주변 통증 → 엉덩이 + 허벅지 근력"/>
-          <p:cNvSpPr txBox="1"/>
-          <p:nvPr/>
-        </p:nvSpPr>
-        <p:spPr>
-          <a:xfrm>
-            <a:off x="822275" y="10531709"/>
+          <p:cNvPr id="9" name="텍스트: 무릎뼈 주변 통증 → 엉덩이 + 허벅지 근력"/>
+          <p:cNvSpPr txBox="1"/>
+          <p:nvPr/>
+        </p:nvSpPr>
+        <p:spPr>
+          <a:xfrm>
+            <a:off x="822275" y="10421874"/>
             <a:ext cx="8642300" cy="409575"/>
           </a:xfrm>
           <a:prstGeom prst="rect">
@@ -4362,7 +4421,7 @@
       </p:sp>
       <p:sp>
         <p:nvSpPr>
-          <p:cNvPr id="9" name="텍스트: Breda SJ et al. Br J Spo"/>
+          <p:cNvPr id="10" name="텍스트: Breda SJ et al. Br J Spo"/>
           <p:cNvSpPr txBox="1"/>
           <p:nvPr/>
         </p:nvSpPr>
@@ -4421,7 +4480,7 @@
       </p:sp>
       <p:sp>
         <p:nvSpPr>
-          <p:cNvPr id="10" name="텍스트: Collins NJ et al. Br J S"/>
+          <p:cNvPr id="11" name="텍스트: Collins NJ et al. Br J S"/>
           <p:cNvSpPr txBox="1"/>
           <p:nvPr/>
         </p:nvSpPr>

</xml_diff>